<commit_message>
content(talks): add Day 3 to TIYA course kit and split materials by day
Day 3, Advanced Agents with Copilot Studio (8:00 AM - 4:00 PM): a 46-slide
deck, workbook, agenda, assessment kit, and facilitator-guide section for
triggered, scheduled, and multi-agent builds, plus a sample inbox and the
work order export as an Excel table.

Every artifact except the facilitator guide is now per day: agendas,
participant pages, assessment kits, SOP pages, and zips. The old combined
participant and agenda URLs become day choosers. Adds Day 2 and Day 3
outlines and a combined approval PDF, and fixes print fragmentation in
grid lists.
</commit_message>
<xml_diff>
--- a/static/presentations/tiya-applied-ai/downloads/day2-slides.pptx
+++ b/static/presentations/tiya-applied-ai/downloads/day2-slides.pptx
@@ -19512,7 +19512,7 @@
                 </a:solidFill>
                 <a:latin typeface="Roboto"/>
               </a:rPr>
-              <a:t>8:30</a:t>
+              <a:t>8:50</a:t>
             </a:r>
           </a:p>
         </p:txBody>
@@ -19590,7 +19590,7 @@
                 </a:solidFill>
                 <a:latin typeface="Roboto"/>
               </a:rPr>
-              <a:t>105 min</a:t>
+              <a:t>85 min</a:t>
             </a:r>
           </a:p>
         </p:txBody>

</xml_diff>